<commit_message>
Tidy the docs: README and guide point to the submission checklist
</commit_message>
<xml_diff>
--- a/docs/presentation.pptx
+++ b/docs/presentation.pptx
@@ -124,38 +124,38 @@
   <p:extLst>
     <p:ext uri="{521415D9-36F7-43E2-AB2F-B90AF26B5E84}">
       <p14:sectionLst xmlns:p14="http://schemas.microsoft.com/office/powerpoint/2010/main">
-        <p14:section name="Opening" id="{8db805c5-d5cf-b18c-52be-b6752b64d46e}">
+        <p14:section name="Opening" id="{34a2e35c-43a6-612f-9afb-daff37a23684}">
           <p14:sldIdLst>
             <p14:sldId id="256"/>
             <p14:sldId id="257"/>
           </p14:sldIdLst>
         </p14:section>
-        <p14:section name="Problem and use case" id="{c0c23b17-b348-31f6-984a-57fd49d3001b}">
+        <p14:section name="Problem and use case" id="{e611795a-0f99-05a6-ec1a-9660ab4a3d4b}">
           <p14:sldIdLst>
             <p14:sldId id="258"/>
             <p14:sldId id="259"/>
           </p14:sldIdLst>
         </p14:section>
-        <p14:section name="Data and architecture" id="{d65d641c-b60c-a748-fc3a-15931c4c45e9}">
+        <p14:section name="Data and architecture" id="{5d403495-3da3-7816-1006-3aa0bd48bce6}">
           <p14:sldIdLst>
             <p14:sldId id="260"/>
             <p14:sldId id="261"/>
           </p14:sldIdLst>
         </p14:section>
-        <p14:section name="How the twin works" id="{7cb4c1b6-dc13-34b3-b2db-8ab70d72ae4a}">
+        <p14:section name="How the twin works" id="{a27fae39-4a2a-b14d-a45e-94bcfdb86603}">
           <p14:sldIdLst>
             <p14:sldId id="262"/>
             <p14:sldId id="263"/>
             <p14:sldId id="264"/>
           </p14:sldIdLst>
         </p14:section>
-        <p14:section name="Results and outcomes" id="{5ab0acd9-67c9-7b39-bb2c-9cd5e122da9c}">
+        <p14:section name="Results and outcomes" id="{a03a3368-c627-e436-7120-867371c525af}">
           <p14:sldIdLst>
             <p14:sldId id="265"/>
             <p14:sldId id="266"/>
           </p14:sldIdLst>
         </p14:section>
-        <p14:section name="Product" id="{204264dd-0805-271a-5624-4926ae86ceb5}">
+        <p14:section name="Product" id="{10a9833a-d3b9-a698-7d95-94764f3156bd}">
           <p14:sldIdLst>
             <p14:sldId id="267"/>
             <p14:sldId id="268"/>
@@ -165,7 +165,7 @@
             <p14:sldId id="272"/>
           </p14:sldIdLst>
         </p14:section>
-        <p14:section name="Team" id="{76ecac8a-4486-cb38-84c4-964d2b21e579}">
+        <p14:section name="Team" id="{38a53a88-f66d-e01e-64e6-63c54f98c07a}">
           <p14:sldIdLst>
             <p14:sldId id="273"/>
           </p14:sldIdLst>
@@ -2023,7 +2023,7 @@
           <a:p>
             <a:r>
               <a:rPr lang="en-US" dirty="0"/>
-              <a:t>Pratibimb is Sanskrit for reflection: a personal model that mirrors one patient's body. We are Team AMAZE from IIM Lucknow. In the next twenty minutes: the problem, the data, how the twin works, what it achieves, and the doctor and patient experience.</a:t>
+              <a:t/>
             </a:r>
             <a:endParaRPr lang="en-US" dirty="0"/>
           </a:p>
@@ -2111,7 +2111,7 @@
           <a:p>
             <a:r>
               <a:rPr lang="en-US" dirty="0"/>
-              <a:t>Left, AUROC: Pratibimb 0.876 against 0.851 for the same streams without the twin, and 0.708 for the NightSignal-style rule. Right, episodes caught at the budget: 70% against 64% without the twin. Watch plus cuff with the twin catches slightly more at the budget; the record raises ranking, not timing. The cuff is what separates strain from a cold: a cold raises heart rate but rarely BP for a week.</a:t>
+              <a:t/>
             </a:r>
             <a:endParaRPr lang="en-US" dirty="0"/>
           </a:p>
@@ -2199,7 +2199,7 @@
           <a:p>
             <a:r>
               <a:rPr lang="en-US" dirty="0"/>
-              <a:t>Because the synthetic generator knows every person's true slopes, we can test whether the twin finds them. Correlation with the truth is 0.59 to 0.71, and the twin beats one slope for everyone on every response, cutting error by 18 to 30 percent. That is what makes the what-if personal and keeps ordinary late nights from becoming alerts.</a:t>
+              <a:t/>
             </a:r>
             <a:endParaRPr lang="en-US" dirty="0"/>
           </a:p>
@@ -2287,7 +2287,7 @@
           <a:p>
             <a:r>
               <a:rPr lang="en-US" dirty="0"/>
-              <a:t>The doctor starts on Today: ten people need attention, 26 are worth a check-in and 204 are steady, with false alerts inside the budget. Opening Meera shows a three-sentence summary, the chance with its likely range, what the twin used from the record and the watch, and a suggested next step.</a:t>
+              <a:t/>
             </a:r>
             <a:endParaRPr lang="en-US" dirty="0"/>
           </a:p>
@@ -2375,7 +2375,7 @@
           <a:p>
             <a:r>
               <a:rPr lang="en-US" dirty="0"/>
-              <a:t>Simulate re-runs the twin with one change. A daily 30 minute walk moves Meera's BP by her own slope. The next 72 hours barely move, because the episode is already under way, but her ordinary-week risk drops by about a quarter. Every alert opens with its reasons, the inputs it used and how well the model does. The budget meter and the 14 day replay keep the doctor in charge.</a:t>
+              <a:t/>
             </a:r>
             <a:endParaRPr lang="en-US" dirty="0"/>
           </a:p>
@@ -2463,7 +2463,7 @@
           <a:p>
             <a:r>
               <a:rPr lang="en-US" dirty="0"/>
-              <a:t>The patient sees one sentence in English or Hindi, with read-aloud, and the habits that help them most by their own slopes. If something feels wrong, press-and-hold SOS starts a consented ladder: the person first, then two contacts, then the doctor, with one tap to 112 at every step. A new user with five nights sees still learning your normal, not a guess.</a:t>
+              <a:t/>
             </a:r>
             <a:endParaRPr lang="en-US" dirty="0"/>
           </a:p>
@@ -2551,7 +2551,7 @@
           <a:p>
             <a:r>
               <a:rPr lang="en-US" dirty="0"/>
-              <a:t>Pratibimb is designed for Indian practice: it reads the budget watches people already own through Health Connect, exports FHIR R4 and the ABDM WellnessRecord bundle, keeps consent per stream as the DPDP Act expects, never prescribes, and has a clear path under CDSCO's Medical Device Software guidance.</a:t>
+              <a:t/>
             </a:r>
             <a:endParaRPr lang="en-US" dirty="0"/>
           </a:p>
@@ -2639,7 +2639,7 @@
           <a:p>
             <a:r>
               <a:rPr lang="en-US" dirty="0"/>
-              <a:t>What we built: a working, leakage-tested prediction model, the personal physiology engine, a full doctor dashboard, a patient app in two languages, FHIR and ABDM export, a live demo and an open-source repository with tests. On a typical day the doctor sees ten people who need attention out of 240, with false alerts inside the budget.</a:t>
+              <a:t/>
             </a:r>
             <a:endParaRPr lang="en-US" dirty="0"/>
           </a:p>
@@ -2727,7 +2727,7 @@
           <a:p>
             <a:r>
               <a:rPr lang="en-US" dirty="0"/>
-              <a:t>Limits: the labels are synthetic, scoring is nightly, we do not detect heart attacks, and the record adds ranking more than timing. The roadmap closes these in order: ABDM sandbox and an Android companion app, a silent-mode clinic pilot on consented real data, a South Asian risk chart and CGM for diabetic patients, then a CDSCO filing.</a:t>
+              <a:t/>
             </a:r>
             <a:endParaRPr lang="en-US" dirty="0"/>
           </a:p>
@@ -2815,7 +2815,7 @@
           <a:p>
             <a:r>
               <a:rPr lang="en-US" dirty="0"/>
-              <a:t>Pratibimb is built by Team AMAZE, Nikita Pandey and Suraj Aryan, from IIM Lucknow. The live demo, the code, the algorithm guide, the model card and the architecture are all public. Thank you.</a:t>
+              <a:t/>
             </a:r>
             <a:endParaRPr lang="en-US" dirty="0"/>
           </a:p>
@@ -2903,7 +2903,7 @@
           <a:p>
             <a:r>
               <a:rPr lang="en-US" dirty="0"/>
-              <a:t>One slide summary. The problem is quiet, days-long strain in hypertensive patients that fixed thresholds either miss or drown in false alarms. Pratibimb builds a personal twin for each patient and alerts only on what their own habits cannot explain. On a synthetic cohort it catches 70% of episodes at one false alert per 22 patient-days, a median 48 hours ahead.</a:t>
+              <a:t/>
             </a:r>
             <a:endParaRPr lang="en-US" dirty="0"/>
           </a:p>
@@ -2991,7 +2991,7 @@
           <a:p>
             <a:r>
               <a:rPr lang="en-US" dirty="0"/>
-              <a:t>About one in four Indian adults has high blood pressure. Over 90% of smartwatches sold in India cost under fifty dollars, and they already record heart rate, sleep and steps every night. Yet fixed thresholds flag more than half of readings in remote monitoring, so doctors stop looking. And people differ: the same short night moves one heart rate by 2 bpm and another by 0.3.</a:t>
+              <a:t/>
             </a:r>
             <a:endParaRPr lang="en-US" dirty="0"/>
           </a:p>
@@ -3079,7 +3079,7 @@
           <a:p>
             <a:r>
               <a:rPr lang="en-US" dirty="0"/>
-              <a:t>The event is a cardiovascular strain episode: overnight heart rate above the person's own baseline, HRV below their smallest worthwhile change, falling sleep and steps and a rising home BP trend, ending in a surge or an unplanned visit. The chart is Meera's real score from the model: quiet for weeks, then climbing from 5 October. We do not claim heart-attack detection; acute events belong to the SOS ladder and 112.</a:t>
+              <a:t/>
             </a:r>
             <a:endParaRPr lang="en-US" dirty="0"/>
           </a:p>
@@ -3167,7 +3167,7 @@
           <a:p>
             <a:r>
               <a:rPr lang="en-US" dirty="0"/>
-              <a:t>Two streams, both synthetic and seeded. The record is Synthea-shaped FHIR R4: demographics, SNOMED diagnoses, LOINC labs, medicines with adherence, family history and a polygenic risk tier. The watch stream is nightly: resting heart rate, HRV, sleep with stages, steps, SpO2, breathing, plus a home BP cuff. Colds, missed doses, late nights and travel are planted so the model has to tell them from real strain.</a:t>
+              <a:t/>
             </a:r>
             <a:endParaRPr lang="en-US" dirty="0"/>
           </a:p>
@@ -3255,7 +3255,7 @@
           <a:p>
             <a:r>
               <a:rPr lang="en-US" dirty="0"/>
-              <a:t>Left to right: the record and the watch stream come in; a companion app reads Health Connect or HealthKit because no website can. The Personal Physiology Engine builds the twin. The fusion model turns twin signals into a calibrated 72 hour probability. The action layer handles alerts, thresholds, the what-if simulator, the check-in ladder, consent and audit. People act at the end.</a:t>
+              <a:t/>
             </a:r>
             <a:endParaRPr lang="en-US" dirty="0"/>
           </a:p>
@@ -3343,7 +3343,7 @@
           <a:p>
             <a:r>
               <a:rPr lang="en-US" dirty="0"/>
-              <a:t>Step one compares tonight with Meera's own last 28 nights: plus 13.8 bpm. Step two learns how her body responds to sleep and steps, on calm days only. Step three borrows strength from the cohort: 57% weight on her own data. Step four subtracts what her habits explain, leaving 12.6 bpm unexplained. Step five fuses that with BP and the record into a calibrated 24% chance in 72 hours, score 63, urgent.</a:t>
+              <a:t/>
             </a:r>
             <a:endParaRPr lang="en-US" dirty="0"/>
           </a:p>
@@ -3431,7 +3431,7 @@
           <a:p>
             <a:r>
               <a:rPr lang="en-US" dirty="0"/>
-              <a:t>Left: tonight Meera is 13.8 bpm above her usual. Her short night and extra steps explain only 1.3 bpm, so 12.6 bpm is unexplained, and that is the warning. Middle: one person's slope is noisy, so the twin mixes it with the cohort's, weighted by how sure we are. Right: her slopes differ from most people's, which is why the what-if advice is personal.</a:t>
+              <a:t/>
             </a:r>
             <a:endParaRPr lang="en-US" dirty="0"/>
           </a:p>
@@ -3519,7 +3519,7 @@
           <a:p>
             <a:r>
               <a:rPr lang="en-US" dirty="0"/>
-              <a:t>The fusion model is LightGBM with monotone constraints, so it can never say more sleep or more walking raises risk. Platt scaling calibrates the probability. The urgent threshold is the most sensitive cut that stays within 0.045 false alerts per patient-day. SHAP turns the score into reasons. Validation is patient-level, repeated over three splits, with leakage tests in the suite.</a:t>
+              <a:t/>
             </a:r>
             <a:endParaRPr lang="en-US" dirty="0"/>
           </a:p>

</xml_diff>